<commit_message>
docs: reestruturar apresentacao de investidores alinhada 100% ao Manifesto v2.0 e Business Plan v2 Gallo
</commit_message>
<xml_diff>
--- a/docs/Apresentacao_Investidores_Netfits_v1.pptx
+++ b/docs/Apresentacao_Investidores_Netfits_v1.pptx
@@ -12,6 +12,11 @@
     <p:sldId id="260" r:id="rId11"/>
     <p:sldId id="261" r:id="rId12"/>
     <p:sldId id="262" r:id="rId13"/>
+    <p:sldId id="263" r:id="rId14"/>
+    <p:sldId id="264" r:id="rId15"/>
+    <p:sldId id="265" r:id="rId16"/>
+    <p:sldId id="266" r:id="rId17"/>
+    <p:sldId id="267" r:id="rId18"/>
   </p:sldIdLst>
   <p:sldSz cx="12191695" cy="6858000" type="screen4x3"/>
   <p:notesSz cx="6858000" cy="9144000"/>
@@ -3090,7 +3095,7 @@
     <p:bg>
       <p:bgPr>
         <a:solidFill>
-          <a:srgbClr val="0F0F14"/>
+          <a:srgbClr val="09090B"/>
         </a:solidFill>
         <a:effectLst/>
       </p:bgPr>
@@ -3110,8 +3115,8 @@
         </p:nvSpPr>
         <p:spPr>
           <a:xfrm>
-            <a:off x="731520" y="1371600"/>
-            <a:ext cx="5943600" cy="4572000"/>
+            <a:off x="914400" y="1645920"/>
+            <a:ext cx="10332720" cy="4114800"/>
           </a:xfrm>
           <a:prstGeom prst="rect">
             <a:avLst/>
@@ -3132,81 +3137,643 @@
               </a:defRPr>
             </a:pPr>
             <a:r>
-              <a:t>NETFITS TECNOLOGIA S.A.</a:t>
-            </a:r>
-          </a:p>
-          <a:p>
-            <a:pPr>
-              <a:defRPr sz="1800" b="1">
-                <a:solidFill>
-                  <a:srgbClr val="84CC16"/>
-                </a:solidFill>
-              </a:defRPr>
-            </a:pPr>
-            <a:r>
-              <a:t>Slogan: "Fazer cada movimento valer mais."</a:t>
-            </a:r>
-          </a:p>
-          <a:p>
+              <a:t>Netfits Fidelidade Ltda.</a:t>
+            </a:r>
+          </a:p>
+          <a:p>
+            <a:pPr>
+              <a:defRPr sz="4400" b="1">
+                <a:solidFill>
+                  <a:srgbClr val="A3E635"/>
+                </a:solidFill>
+              </a:defRPr>
+            </a:pPr>
+            <a:r>
+              <a:t>Fazer cada movimento valer mais.</a:t>
+            </a:r>
+          </a:p>
+          <a:p>
+            <a:pPr>
+              <a:defRPr sz="1600">
+                <a:solidFill>
+                  <a:srgbClr val="FFFFFF"/>
+                </a:solidFill>
+              </a:defRPr>
+            </a:pPr>
+            <a:r>
+              <a:t>A camada de valor e fidelidade verticalizada para o estilo de vida ativo e a longevidade consciente na América Latina.</a:t>
+            </a:r>
             <a:br/>
+          </a:p>
+          <a:p>
             <a:pPr>
               <a:defRPr sz="1400" b="1">
                 <a:solidFill>
-                  <a:srgbClr val="FFFFFF"/>
-                </a:solidFill>
-              </a:defRPr>
-            </a:pPr>
-            <a:r>
-              <a:t>Apresentação Executiva de Negócio (Rodada Seed: R$ 4M a R$ 8M)</a:t>
-            </a:r>
-          </a:p>
-          <a:p>
+                  <a:srgbClr val="A1A1AA"/>
+                </a:solidFill>
+              </a:defRPr>
+            </a:pPr>
+            <a:r>
+              <a:t>• Rodada Solicitada: Seed / Series A (R$ 4,0M a R$ 8,0M)</a:t>
+            </a:r>
             <a:br/>
-            <a:pPr>
-              <a:defRPr sz="1200">
-                <a:solidFill>
-                  <a:srgbClr val="A1A1AA"/>
-                </a:solidFill>
-              </a:defRPr>
-            </a:pPr>
-            <a:r>
-              <a:t>• Etapa 1: Benefícios (Valor Imediato — Feed, nfs, Shop &amp; Bancos)</a:t>
-            </a:r>
-            <a:br/>
-            <a:r>
-              <a:t>• Etapa 2: Hábitos (Valor Recorrente — Wearables &amp; Clube R$ 19,90/m)</a:t>
-            </a:r>
-            <a:br/>
-            <a:r>
-              <a:t>• Etapa 3: Longevidade (Valor para Sempre — Saúde Preventiva &amp; B2B)</a:t>
-            </a:r>
-          </a:p>
-        </p:txBody>
-      </p:sp>
-      <p:pic>
-        <p:nvPicPr>
-          <p:cNvPr id="3" name="Picture 2" descr="real_netfits_feed.png"/>
-          <p:cNvPicPr>
-            <a:picLocks noChangeAspect="1"/>
-          </p:cNvPicPr>
+            <a:r>
+              <a:t>• Estágio: MVP Lançado &amp; Operação Atuarial Definida</a:t>
+            </a:r>
+          </a:p>
+        </p:txBody>
+      </p:sp>
+    </p:spTree>
+  </p:cSld>
+  <p:clrMapOvr>
+    <a:masterClrMapping/>
+  </p:clrMapOvr>
+</p:sld>
+</file>
+
+<file path=ppt/slides/slide10.xml><?xml version="1.0" encoding="utf-8"?>
+<p:sld xmlns:a="http://schemas.openxmlformats.org/drawingml/2006/main" xmlns:p="http://schemas.openxmlformats.org/presentationml/2006/main" xmlns:r="http://schemas.openxmlformats.org/officeDocument/2006/relationships">
+  <p:cSld>
+    <p:bg>
+      <p:bgPr>
+        <a:solidFill>
+          <a:srgbClr val="09090B"/>
+        </a:solidFill>
+        <a:effectLst/>
+      </p:bgPr>
+    </p:bg>
+    <p:spTree>
+      <p:nvGrpSpPr>
+        <p:cNvPr id="1" name=""/>
+        <p:cNvGrpSpPr/>
+        <p:nvPr/>
+      </p:nvGrpSpPr>
+      <p:grpSpPr/>
+      <p:sp>
+        <p:nvSpPr>
+          <p:cNvPr id="2" name="TextBox 1"/>
+          <p:cNvSpPr txBox="1"/>
           <p:nvPr/>
-        </p:nvPicPr>
-        <p:blipFill>
-          <a:blip r:embed="rId2"/>
-          <a:stretch>
-            <a:fillRect/>
-          </a:stretch>
-        </p:blipFill>
+        </p:nvSpPr>
         <p:spPr>
           <a:xfrm>
-            <a:off x="6766560" y="1188720"/>
-            <a:ext cx="4754880" cy="3343275"/>
+            <a:off x="731520" y="365760"/>
+            <a:ext cx="10698480" cy="822960"/>
           </a:xfrm>
           <a:prstGeom prst="rect">
             <a:avLst/>
           </a:prstGeom>
+          <a:noFill/>
         </p:spPr>
-      </p:pic>
+        <p:txBody>
+          <a:bodyPr wrap="square">
+            <a:spAutoFit/>
+          </a:bodyPr>
+          <a:lstStyle/>
+          <a:p>
+            <a:pPr>
+              <a:defRPr sz="1000" b="1">
+                <a:solidFill>
+                  <a:srgbClr val="A3E635"/>
+                </a:solidFill>
+              </a:defRPr>
+            </a:pPr>
+            <a:r>
+              <a:t>NETFITS FIDELIDADE LTDA.</a:t>
+            </a:r>
+          </a:p>
+          <a:p>
+            <a:pPr>
+              <a:defRPr sz="2200" b="1">
+                <a:solidFill>
+                  <a:srgbClr val="FFFFFF"/>
+                </a:solidFill>
+              </a:defRPr>
+            </a:pPr>
+            <a:r>
+              <a:t>🛡️ Moat Competitivo Tecnológico &amp; Defensabilidade</a:t>
+            </a:r>
+          </a:p>
+        </p:txBody>
+      </p:sp>
+      <p:sp>
+        <p:nvSpPr>
+          <p:cNvPr id="3" name="TextBox 2"/>
+          <p:cNvSpPr txBox="1"/>
+          <p:nvPr/>
+        </p:nvSpPr>
+        <p:spPr>
+          <a:xfrm>
+            <a:off x="731520" y="1463040"/>
+            <a:ext cx="10698480" cy="4572000"/>
+          </a:xfrm>
+          <a:prstGeom prst="rect">
+            <a:avLst/>
+          </a:prstGeom>
+          <a:noFill/>
+        </p:spPr>
+        <p:txBody>
+          <a:bodyPr wrap="square">
+            <a:spAutoFit/>
+          </a:bodyPr>
+          <a:lstStyle/>
+          <a:p/>
+          <a:p>
+            <a:pPr>
+              <a:defRPr sz="1400" b="1">
+                <a:solidFill>
+                  <a:srgbClr val="C084FC"/>
+                </a:solidFill>
+              </a:defRPr>
+            </a:pPr>
+            <a:r>
+              <a:t>• Verticalização Exclusiva: </a:t>
+            </a:r>
+          </a:p>
+          <a:p>
+            <a:pPr>
+              <a:defRPr sz="1200">
+                <a:solidFill>
+                  <a:srgbClr val="FFFFFF"/>
+                </a:solidFill>
+              </a:defRPr>
+            </a:pPr>
+            <a:r>
+              <a:t>  Plataforma focada 100% no esportista amador e no estilo de vida ativo.</a:t>
+            </a:r>
+            <a:br/>
+          </a:p>
+          <a:p>
+            <a:pPr>
+              <a:defRPr sz="1400" b="1">
+                <a:solidFill>
+                  <a:srgbClr val="C084FC"/>
+                </a:solidFill>
+              </a:defRPr>
+            </a:pPr>
+            <a:r>
+              <a:t>• Algoritmo FEFO Protegido: </a:t>
+            </a:r>
+          </a:p>
+          <a:p>
+            <a:pPr>
+              <a:defRPr sz="1200">
+                <a:solidFill>
+                  <a:srgbClr val="FFFFFF"/>
+                </a:solidFill>
+              </a:defRPr>
+            </a:pPr>
+            <a:r>
+              <a:t>  Gestão atuarial automática de passivos e expiração de pontos sem risco de caixa.</a:t>
+            </a:r>
+            <a:br/>
+          </a:p>
+          <a:p>
+            <a:pPr>
+              <a:defRPr sz="1400" b="1">
+                <a:solidFill>
+                  <a:srgbClr val="C084FC"/>
+                </a:solidFill>
+              </a:defRPr>
+            </a:pPr>
+            <a:r>
+              <a:t>• Efeito de Rede de Associados: </a:t>
+            </a:r>
+          </a:p>
+          <a:p>
+            <a:pPr>
+              <a:defRPr sz="1200">
+                <a:solidFill>
+                  <a:srgbClr val="FFFFFF"/>
+                </a:solidFill>
+              </a:defRPr>
+            </a:pPr>
+            <a:r>
+              <a:t>  Carteiras compartilhadas com criadores criam barreira de saída inigualável.</a:t>
+            </a:r>
+            <a:br/>
+          </a:p>
+          <a:p>
+            <a:pPr>
+              <a:defRPr sz="1400" b="1">
+                <a:solidFill>
+                  <a:srgbClr val="C084FC"/>
+                </a:solidFill>
+              </a:defRPr>
+            </a:pPr>
+            <a:r>
+              <a:t>• Wearables &amp; Longevidade: </a:t>
+            </a:r>
+          </a:p>
+          <a:p>
+            <a:pPr>
+              <a:defRPr sz="1200">
+                <a:solidFill>
+                  <a:srgbClr val="FFFFFF"/>
+                </a:solidFill>
+              </a:defRPr>
+            </a:pPr>
+            <a:r>
+              <a:t>  Integração de dados consentidos de treino e transição natural para longevidade.</a:t>
+            </a:r>
+            <a:br/>
+          </a:p>
+        </p:txBody>
+      </p:sp>
+    </p:spTree>
+  </p:cSld>
+  <p:clrMapOvr>
+    <a:masterClrMapping/>
+  </p:clrMapOvr>
+</p:sld>
+</file>
+
+<file path=ppt/slides/slide11.xml><?xml version="1.0" encoding="utf-8"?>
+<p:sld xmlns:a="http://schemas.openxmlformats.org/drawingml/2006/main" xmlns:p="http://schemas.openxmlformats.org/presentationml/2006/main" xmlns:r="http://schemas.openxmlformats.org/officeDocument/2006/relationships">
+  <p:cSld>
+    <p:bg>
+      <p:bgPr>
+        <a:solidFill>
+          <a:srgbClr val="09090B"/>
+        </a:solidFill>
+        <a:effectLst/>
+      </p:bgPr>
+    </p:bg>
+    <p:spTree>
+      <p:nvGrpSpPr>
+        <p:cNvPr id="1" name=""/>
+        <p:cNvGrpSpPr/>
+        <p:nvPr/>
+      </p:nvGrpSpPr>
+      <p:grpSpPr/>
+      <p:sp>
+        <p:nvSpPr>
+          <p:cNvPr id="2" name="TextBox 1"/>
+          <p:cNvSpPr txBox="1"/>
+          <p:nvPr/>
+        </p:nvSpPr>
+        <p:spPr>
+          <a:xfrm>
+            <a:off x="731520" y="365760"/>
+            <a:ext cx="10698480" cy="822960"/>
+          </a:xfrm>
+          <a:prstGeom prst="rect">
+            <a:avLst/>
+          </a:prstGeom>
+          <a:noFill/>
+        </p:spPr>
+        <p:txBody>
+          <a:bodyPr wrap="square">
+            <a:spAutoFit/>
+          </a:bodyPr>
+          <a:lstStyle/>
+          <a:p>
+            <a:pPr>
+              <a:defRPr sz="1000" b="1">
+                <a:solidFill>
+                  <a:srgbClr val="A3E635"/>
+                </a:solidFill>
+              </a:defRPr>
+            </a:pPr>
+            <a:r>
+              <a:t>NETFITS FIDELIDADE LTDA.</a:t>
+            </a:r>
+          </a:p>
+          <a:p>
+            <a:pPr>
+              <a:defRPr sz="2200" b="1">
+                <a:solidFill>
+                  <a:srgbClr val="FFFFFF"/>
+                </a:solidFill>
+              </a:defRPr>
+            </a:pPr>
+            <a:r>
+              <a:t>💰 Uso dos Recursos da Captação (R$ 4,0M a R$ 8,0M)</a:t>
+            </a:r>
+          </a:p>
+        </p:txBody>
+      </p:sp>
+      <p:sp>
+        <p:nvSpPr>
+          <p:cNvPr id="3" name="TextBox 2"/>
+          <p:cNvSpPr txBox="1"/>
+          <p:nvPr/>
+        </p:nvSpPr>
+        <p:spPr>
+          <a:xfrm>
+            <a:off x="731520" y="1463040"/>
+            <a:ext cx="10698480" cy="4572000"/>
+          </a:xfrm>
+          <a:prstGeom prst="rect">
+            <a:avLst/>
+          </a:prstGeom>
+          <a:noFill/>
+        </p:spPr>
+        <p:txBody>
+          <a:bodyPr wrap="square">
+            <a:spAutoFit/>
+          </a:bodyPr>
+          <a:lstStyle/>
+          <a:p/>
+          <a:p>
+            <a:pPr>
+              <a:defRPr sz="1300" b="1">
+                <a:solidFill>
+                  <a:srgbClr val="A3E635"/>
+                </a:solidFill>
+              </a:defRPr>
+            </a:pPr>
+            <a:r>
+              <a:t>• 40% — Produto e Tecnologia: </a:t>
+            </a:r>
+          </a:p>
+          <a:p>
+            <a:pPr>
+              <a:defRPr sz="1100">
+                <a:solidFill>
+                  <a:srgbClr val="FFFFFF"/>
+                </a:solidFill>
+              </a:defRPr>
+            </a:pPr>
+            <a:r>
+              <a:t>  Evolução do App native-shell, algoritmo FEFO e conectores de wearables.</a:t>
+            </a:r>
+            <a:br/>
+          </a:p>
+          <a:p>
+            <a:pPr>
+              <a:defRPr sz="1300" b="1">
+                <a:solidFill>
+                  <a:srgbClr val="A3E635"/>
+                </a:solidFill>
+              </a:defRPr>
+            </a:pPr>
+            <a:r>
+              <a:t>• 25% — Aquisição e Crescimento: </a:t>
+            </a:r>
+          </a:p>
+          <a:p>
+            <a:pPr>
+              <a:defRPr sz="1100">
+                <a:solidFill>
+                  <a:srgbClr val="FFFFFF"/>
+                </a:solidFill>
+              </a:defRPr>
+            </a:pPr>
+            <a:r>
+              <a:t>  Marketing de comunidade, presença em provas esportivas e programa MGM.</a:t>
+            </a:r>
+            <a:br/>
+          </a:p>
+          <a:p>
+            <a:pPr>
+              <a:defRPr sz="1300" b="1">
+                <a:solidFill>
+                  <a:srgbClr val="A3E635"/>
+                </a:solidFill>
+              </a:defRPr>
+            </a:pPr>
+            <a:r>
+              <a:t>• 15% — Parcerias &amp; Rede de Associados: </a:t>
+            </a:r>
+          </a:p>
+          <a:p>
+            <a:pPr>
+              <a:defRPr sz="1100">
+                <a:solidFill>
+                  <a:srgbClr val="FFFFFF"/>
+                </a:solidFill>
+              </a:defRPr>
+            </a:pPr>
+            <a:r>
+              <a:t>  Expansão da rede B2B2C e comissionamento padrão de 10,0%.</a:t>
+            </a:r>
+            <a:br/>
+          </a:p>
+          <a:p>
+            <a:pPr>
+              <a:defRPr sz="1300" b="1">
+                <a:solidFill>
+                  <a:srgbClr val="A3E635"/>
+                </a:solidFill>
+              </a:defRPr>
+            </a:pPr>
+            <a:r>
+              <a:t>• 10% — BI, Antifraude &amp; Wearables: </a:t>
+            </a:r>
+          </a:p>
+          <a:p>
+            <a:pPr>
+              <a:defRPr sz="1100">
+                <a:solidFill>
+                  <a:srgbClr val="FFFFFF"/>
+                </a:solidFill>
+              </a:defRPr>
+            </a:pPr>
+            <a:r>
+              <a:t>  Motor de inteligência de dados comportamentais e inteligência artificial.</a:t>
+            </a:r>
+            <a:br/>
+          </a:p>
+          <a:p>
+            <a:pPr>
+              <a:defRPr sz="1300" b="1">
+                <a:solidFill>
+                  <a:srgbClr val="A3E635"/>
+                </a:solidFill>
+              </a:defRPr>
+            </a:pPr>
+            <a:r>
+              <a:t>• 10% — Jurídico, Compliance &amp; Operações: </a:t>
+            </a:r>
+          </a:p>
+          <a:p>
+            <a:pPr>
+              <a:defRPr sz="1100">
+                <a:solidFill>
+                  <a:srgbClr val="FFFFFF"/>
+                </a:solidFill>
+              </a:defRPr>
+            </a:pPr>
+            <a:r>
+              <a:t>  Estrutura regulatória, governança e equipe de suporte.</a:t>
+            </a:r>
+            <a:br/>
+          </a:p>
+        </p:txBody>
+      </p:sp>
+    </p:spTree>
+  </p:cSld>
+  <p:clrMapOvr>
+    <a:masterClrMapping/>
+  </p:clrMapOvr>
+</p:sld>
+</file>
+
+<file path=ppt/slides/slide12.xml><?xml version="1.0" encoding="utf-8"?>
+<p:sld xmlns:a="http://schemas.openxmlformats.org/drawingml/2006/main" xmlns:p="http://schemas.openxmlformats.org/presentationml/2006/main" xmlns:r="http://schemas.openxmlformats.org/officeDocument/2006/relationships">
+  <p:cSld>
+    <p:bg>
+      <p:bgPr>
+        <a:solidFill>
+          <a:srgbClr val="09090B"/>
+        </a:solidFill>
+        <a:effectLst/>
+      </p:bgPr>
+    </p:bg>
+    <p:spTree>
+      <p:nvGrpSpPr>
+        <p:cNvPr id="1" name=""/>
+        <p:cNvGrpSpPr/>
+        <p:nvPr/>
+      </p:nvGrpSpPr>
+      <p:grpSpPr/>
+      <p:sp>
+        <p:nvSpPr>
+          <p:cNvPr id="2" name="TextBox 1"/>
+          <p:cNvSpPr txBox="1"/>
+          <p:nvPr/>
+        </p:nvSpPr>
+        <p:spPr>
+          <a:xfrm>
+            <a:off x="731520" y="365760"/>
+            <a:ext cx="10698480" cy="822960"/>
+          </a:xfrm>
+          <a:prstGeom prst="rect">
+            <a:avLst/>
+          </a:prstGeom>
+          <a:noFill/>
+        </p:spPr>
+        <p:txBody>
+          <a:bodyPr wrap="square">
+            <a:spAutoFit/>
+          </a:bodyPr>
+          <a:lstStyle/>
+          <a:p>
+            <a:pPr>
+              <a:defRPr sz="1000" b="1">
+                <a:solidFill>
+                  <a:srgbClr val="A3E635"/>
+                </a:solidFill>
+              </a:defRPr>
+            </a:pPr>
+            <a:r>
+              <a:t>NETFITS FIDELIDADE LTDA.</a:t>
+            </a:r>
+          </a:p>
+          <a:p>
+            <a:pPr>
+              <a:defRPr sz="2200" b="1">
+                <a:solidFill>
+                  <a:srgbClr val="FFFFFF"/>
+                </a:solidFill>
+              </a:defRPr>
+            </a:pPr>
+            <a:r>
+              <a:t>🌟 O Código Netfits &amp; Visão de Longo Prazo</a:t>
+            </a:r>
+          </a:p>
+        </p:txBody>
+      </p:sp>
+      <p:sp>
+        <p:nvSpPr>
+          <p:cNvPr id="3" name="TextBox 2"/>
+          <p:cNvSpPr txBox="1"/>
+          <p:nvPr/>
+        </p:nvSpPr>
+        <p:spPr>
+          <a:xfrm>
+            <a:off x="731520" y="1463040"/>
+            <a:ext cx="10698480" cy="4572000"/>
+          </a:xfrm>
+          <a:prstGeom prst="rect">
+            <a:avLst/>
+          </a:prstGeom>
+          <a:noFill/>
+        </p:spPr>
+        <p:txBody>
+          <a:bodyPr wrap="square">
+            <a:spAutoFit/>
+          </a:bodyPr>
+          <a:lstStyle/>
+          <a:p/>
+          <a:p>
+            <a:pPr>
+              <a:defRPr sz="1400" b="1">
+                <a:solidFill>
+                  <a:srgbClr val="C084FC"/>
+                </a:solidFill>
+              </a:defRPr>
+            </a:pPr>
+            <a:r>
+              <a:t>• O Código Netfits: </a:t>
+            </a:r>
+          </a:p>
+          <a:p>
+            <a:pPr>
+              <a:defRPr sz="1200">
+                <a:solidFill>
+                  <a:srgbClr val="FFFFFF"/>
+                </a:solidFill>
+              </a:defRPr>
+            </a:pPr>
+            <a:r>
+              <a:t>  1. Usuário antes do ego | 2. Clareza antes da complexidade | 3. Evidência antes da convicção | 4. Velocidade com responsabilidade.</a:t>
+            </a:r>
+            <a:br/>
+          </a:p>
+          <a:p>
+            <a:pPr>
+              <a:defRPr sz="1400" b="1">
+                <a:solidFill>
+                  <a:srgbClr val="C084FC"/>
+                </a:solidFill>
+              </a:defRPr>
+            </a:pPr>
+            <a:r>
+              <a:t>• Visão de Longo Prazo: </a:t>
+            </a:r>
+          </a:p>
+          <a:p>
+            <a:pPr>
+              <a:defRPr sz="1200">
+                <a:solidFill>
+                  <a:srgbClr val="FFFFFF"/>
+                </a:solidFill>
+              </a:defRPr>
+            </a:pPr>
+            <a:r>
+              <a:t>  Ser a plataforma de referência na América Latina para a jornada ativa e longeva.</a:t>
+            </a:r>
+            <a:br/>
+          </a:p>
+          <a:p>
+            <a:pPr>
+              <a:defRPr sz="1400" b="1">
+                <a:solidFill>
+                  <a:srgbClr val="C084FC"/>
+                </a:solidFill>
+              </a:defRPr>
+            </a:pPr>
+            <a:r>
+              <a:t>• Netfits Fidelidade Ltda.: </a:t>
+            </a:r>
+          </a:p>
+          <a:p>
+            <a:pPr>
+              <a:defRPr sz="1200">
+                <a:solidFill>
+                  <a:srgbClr val="FFFFFF"/>
+                </a:solidFill>
+              </a:defRPr>
+            </a:pPr>
+            <a:r>
+              <a:t>  Contato: diretoria@netfits.com.br | www.netfits.com.br</a:t>
+            </a:r>
+            <a:br/>
+          </a:p>
+        </p:txBody>
+      </p:sp>
     </p:spTree>
   </p:cSld>
   <p:clrMapOvr>
@@ -3221,7 +3788,7 @@
     <p:bg>
       <p:bgPr>
         <a:solidFill>
-          <a:srgbClr val="0F0F14"/>
+          <a:srgbClr val="09090B"/>
         </a:solidFill>
         <a:effectLst/>
       </p:bgPr>
@@ -3258,13 +3825,12 @@
             <a:pPr>
               <a:defRPr sz="1000" b="1">
                 <a:solidFill>
-                  <a:srgbClr val="84CC16"/>
-                </a:solidFill>
-                <a:latin typeface="Calibri"/>
-              </a:defRPr>
-            </a:pPr>
-            <a:r>
-              <a:t>NETFITS TECNOLOGIA S.A.</a:t>
+                  <a:srgbClr val="A3E635"/>
+                </a:solidFill>
+              </a:defRPr>
+            </a:pPr>
+            <a:r>
+              <a:t>NETFITS FIDELIDADE LTDA.</a:t>
             </a:r>
           </a:p>
           <a:p>
@@ -3273,69 +3839,74 @@
                 <a:solidFill>
                   <a:srgbClr val="FFFFFF"/>
                 </a:solidFill>
-                <a:latin typeface="Calibri"/>
-              </a:defRPr>
-            </a:pPr>
-            <a:r>
-              <a:t>⚠️ O Problema do Mercado (The Problem)</a:t>
-            </a:r>
-          </a:p>
-        </p:txBody>
-      </p:sp>
-      <p:sp>
-        <p:nvSpPr>
-          <p:cNvPr id="3" name="Rounded Rectangle 2"/>
-          <p:cNvSpPr/>
+              </a:defRPr>
+            </a:pPr>
+            <a:r>
+              <a:t>⚠️ O Problema: A Jornada Fragmentada da Vida Ativa</a:t>
+            </a:r>
+          </a:p>
+        </p:txBody>
+      </p:sp>
+      <p:sp>
+        <p:nvSpPr>
+          <p:cNvPr id="3" name="TextBox 2"/>
+          <p:cNvSpPr txBox="1"/>
           <p:nvPr/>
         </p:nvSpPr>
         <p:spPr>
           <a:xfrm>
-            <a:off x="731520" y="1645920"/>
-            <a:ext cx="3291840" cy="4114800"/>
+            <a:off x="731520" y="1463040"/>
+            <a:ext cx="10698480" cy="4572000"/>
           </a:xfrm>
-          <a:prstGeom prst="roundRect">
+          <a:prstGeom prst="rect">
             <a:avLst/>
           </a:prstGeom>
-          <a:solidFill>
-            <a:srgbClr val="18181B"/>
-          </a:solidFill>
-          <a:ln>
-            <a:solidFill>
-              <a:srgbClr val="7E22CE"/>
-            </a:solidFill>
-          </a:ln>
+          <a:noFill/>
         </p:spPr>
-        <p:style>
-          <a:lnRef idx="1">
-            <a:schemeClr val="accent1"/>
-          </a:lnRef>
-          <a:fillRef idx="3">
-            <a:schemeClr val="accent1"/>
-          </a:fillRef>
-          <a:effectRef idx="2">
-            <a:schemeClr val="accent1"/>
-          </a:effectRef>
-          <a:fontRef idx="minor">
-            <a:schemeClr val="lt1"/>
-          </a:fontRef>
-        </p:style>
-        <p:txBody>
-          <a:bodyPr rtlCol="0" anchor="ctr" wrap="square"/>
-          <a:lstStyle/>
-          <a:p>
-            <a:pPr algn="ctr">
+        <p:txBody>
+          <a:bodyPr wrap="square">
+            <a:spAutoFit/>
+          </a:bodyPr>
+          <a:lstStyle/>
+          <a:p/>
+          <a:p>
+            <a:pPr>
               <a:defRPr sz="1600" b="1">
                 <a:solidFill>
-                  <a:srgbClr val="84CC16"/>
-                </a:solidFill>
-              </a:defRPr>
-            </a:pPr>
-            <a:r>
-              <a:t>1. Churn Elevado (&gt;65%)</a:t>
-            </a:r>
-          </a:p>
-          <a:p>
+                  <a:srgbClr val="C084FC"/>
+                </a:solidFill>
+              </a:defRPr>
+            </a:pPr>
+            <a:r>
+              <a:t>• Valor Disperso no Esporte: </a:t>
+            </a:r>
+          </a:p>
+          <a:p>
+            <a:pPr>
+              <a:defRPr sz="1300">
+                <a:solidFill>
+                  <a:srgbClr val="FFFFFF"/>
+                </a:solidFill>
+              </a:defRPr>
+            </a:pPr>
+            <a:r>
+              <a:t>  O esportista amador gera atenção, consumo, engajamento, dados e frequência, mas esse valor fica espalhado entre redes sociais, WhatsApp e e-commerce genérico.</a:t>
+            </a:r>
             <a:br/>
+          </a:p>
+          <a:p>
+            <a:pPr>
+              <a:defRPr sz="1600" b="1">
+                <a:solidFill>
+                  <a:srgbClr val="C084FC"/>
+                </a:solidFill>
+              </a:defRPr>
+            </a:pPr>
+            <a:r>
+              <a:t>• Pontos Bancários Distantes: </a:t>
+            </a:r>
+          </a:p>
+          <a:p>
             <a:pPr>
               <a:defRPr sz="1300">
                 <a:solidFill>
@@ -3344,142 +3915,34 @@
               </a:defRPr>
             </a:pPr>
             <a:r>
-              <a:t>Praticantes ativos abandonam academias e apps nos primeiros 90 dias por falta de incentivos tangíveis.</a:t>
-            </a:r>
-          </a:p>
-        </p:txBody>
-      </p:sp>
-      <p:sp>
-        <p:nvSpPr>
-          <p:cNvPr id="4" name="Rounded Rectangle 3"/>
-          <p:cNvSpPr/>
-          <p:nvPr/>
-        </p:nvSpPr>
-        <p:spPr>
-          <a:xfrm>
-            <a:off x="4297680" y="1645920"/>
-            <a:ext cx="3291840" cy="4114800"/>
-          </a:xfrm>
-          <a:prstGeom prst="roundRect">
-            <a:avLst/>
-          </a:prstGeom>
-          <a:solidFill>
-            <a:srgbClr val="18181B"/>
-          </a:solidFill>
-          <a:ln>
-            <a:solidFill>
-              <a:srgbClr val="7E22CE"/>
-            </a:solidFill>
-          </a:ln>
-        </p:spPr>
-        <p:style>
-          <a:lnRef idx="1">
-            <a:schemeClr val="accent1"/>
-          </a:lnRef>
-          <a:fillRef idx="3">
-            <a:schemeClr val="accent1"/>
-          </a:fillRef>
-          <a:effectRef idx="2">
-            <a:schemeClr val="accent1"/>
-          </a:effectRef>
-          <a:fontRef idx="minor">
-            <a:schemeClr val="lt1"/>
-          </a:fontRef>
-        </p:style>
-        <p:txBody>
-          <a:bodyPr rtlCol="0" anchor="ctr" wrap="square"/>
-          <a:lstStyle/>
-          <a:p>
-            <a:pPr algn="ctr">
+              <a:t>  Pontos tradicionais de bancos não dialogam com os interesses do praticante de esportes e não recompensam a consistência de hábitos saudáveis.</a:t>
+            </a:r>
+            <a:br/>
+          </a:p>
+          <a:p>
+            <a:pPr>
               <a:defRPr sz="1600" b="1">
                 <a:solidFill>
-                  <a:srgbClr val="84CC16"/>
-                </a:solidFill>
-              </a:defRPr>
-            </a:pPr>
-            <a:r>
-              <a:t>2. CAC Explosivo</a:t>
-            </a:r>
-          </a:p>
-          <a:p>
+                  <a:srgbClr val="C084FC"/>
+                </a:solidFill>
+              </a:defRPr>
+            </a:pPr>
+            <a:r>
+              <a:t>• Falta de Retorno ao Usuário: </a:t>
+            </a:r>
+          </a:p>
+          <a:p>
+            <a:pPr>
+              <a:defRPr sz="1300">
+                <a:solidFill>
+                  <a:srgbClr val="FFFFFF"/>
+                </a:solidFill>
+              </a:defRPr>
+            </a:pPr>
+            <a:r>
+              <a:t>  O praticante de corrida, bike, treino ou outdoor consome equipamentos e conteúdo constante, mas raramente recebe benefícios reais por sua disciplina.</a:t>
+            </a:r>
             <a:br/>
-            <a:pPr>
-              <a:defRPr sz="1300">
-                <a:solidFill>
-                  <a:srgbClr val="FFFFFF"/>
-                </a:solidFill>
-              </a:defRPr>
-            </a:pPr>
-            <a:r>
-              <a:t>Marcas esportivas e clínicas gastam fortunas em mídia paga tradicional com conversão cada vez menor.</a:t>
-            </a:r>
-          </a:p>
-        </p:txBody>
-      </p:sp>
-      <p:sp>
-        <p:nvSpPr>
-          <p:cNvPr id="5" name="Rounded Rectangle 4"/>
-          <p:cNvSpPr/>
-          <p:nvPr/>
-        </p:nvSpPr>
-        <p:spPr>
-          <a:xfrm>
-            <a:off x="7863840" y="1645920"/>
-            <a:ext cx="3291840" cy="4114800"/>
-          </a:xfrm>
-          <a:prstGeom prst="roundRect">
-            <a:avLst/>
-          </a:prstGeom>
-          <a:solidFill>
-            <a:srgbClr val="18181B"/>
-          </a:solidFill>
-          <a:ln>
-            <a:solidFill>
-              <a:srgbClr val="7E22CE"/>
-            </a:solidFill>
-          </a:ln>
-        </p:spPr>
-        <p:style>
-          <a:lnRef idx="1">
-            <a:schemeClr val="accent1"/>
-          </a:lnRef>
-          <a:fillRef idx="3">
-            <a:schemeClr val="accent1"/>
-          </a:fillRef>
-          <a:effectRef idx="2">
-            <a:schemeClr val="accent1"/>
-          </a:effectRef>
-          <a:fontRef idx="minor">
-            <a:schemeClr val="lt1"/>
-          </a:fontRef>
-        </p:style>
-        <p:txBody>
-          <a:bodyPr rtlCol="0" anchor="ctr" wrap="square"/>
-          <a:lstStyle/>
-          <a:p>
-            <a:pPr algn="ctr">
-              <a:defRPr sz="1600" b="1">
-                <a:solidFill>
-                  <a:srgbClr val="84CC16"/>
-                </a:solidFill>
-              </a:defRPr>
-            </a:pPr>
-            <a:r>
-              <a:t>3. Pontos Tradicionais Quebrados</a:t>
-            </a:r>
-          </a:p>
-          <a:p>
-            <a:br/>
-            <a:pPr>
-              <a:defRPr sz="1300">
-                <a:solidFill>
-                  <a:srgbClr val="FFFFFF"/>
-                </a:solidFill>
-              </a:defRPr>
-            </a:pPr>
-            <a:r>
-              <a:t>Pontos expirados sem aviso e regras punitivas desestimulam a fidelização do consumidor.</a:t>
-            </a:r>
           </a:p>
         </p:txBody>
       </p:sp>
@@ -3497,7 +3960,7 @@
     <p:bg>
       <p:bgPr>
         <a:solidFill>
-          <a:srgbClr val="0F0F14"/>
+          <a:srgbClr val="09090B"/>
         </a:solidFill>
         <a:effectLst/>
       </p:bgPr>
@@ -3534,13 +3997,12 @@
             <a:pPr>
               <a:defRPr sz="1000" b="1">
                 <a:solidFill>
-                  <a:srgbClr val="84CC16"/>
-                </a:solidFill>
-                <a:latin typeface="Calibri"/>
-              </a:defRPr>
-            </a:pPr>
-            <a:r>
-              <a:t>NETFITS TECNOLOGIA S.A.</a:t>
+                  <a:srgbClr val="A3E635"/>
+                </a:solidFill>
+              </a:defRPr>
+            </a:pPr>
+            <a:r>
+              <a:t>NETFITS FIDELIDADE LTDA.</a:t>
             </a:r>
           </a:p>
           <a:p>
@@ -3549,11 +4011,10 @@
                 <a:solidFill>
                   <a:srgbClr val="FFFFFF"/>
                 </a:solidFill>
-                <a:latin typeface="Calibri"/>
-              </a:defRPr>
-            </a:pPr>
-            <a:r>
-              <a:t>💡 A Solução Netfits — Captura Real do Feed do App</a:t>
+              </a:defRPr>
+            </a:pPr>
+            <a:r>
+              <a:t>🚀 A Solução Netfits: Ecossistema 4 em 1 &amp; 3 Camadas de Evolução</a:t>
             </a:r>
           </a:p>
         </p:txBody>
@@ -3566,8 +4027,8 @@
         </p:nvSpPr>
         <p:spPr>
           <a:xfrm>
-            <a:off x="731520" y="1463040"/>
-            <a:ext cx="5486400" cy="4572000"/>
+            <a:off x="731520" y="1371600"/>
+            <a:ext cx="5669280" cy="4846320"/>
           </a:xfrm>
           <a:prstGeom prst="rect">
             <a:avLst/>
@@ -3582,14 +4043,14 @@
           <a:p/>
           <a:p>
             <a:pPr>
-              <a:defRPr sz="1200" b="1">
-                <a:solidFill>
-                  <a:srgbClr val="84CC16"/>
-                </a:solidFill>
-              </a:defRPr>
-            </a:pPr>
-            <a:r>
-              <a:t>• Feed Editorial Curado &amp; Recompensas: </a:t>
+              <a:defRPr sz="1300" b="1">
+                <a:solidFill>
+                  <a:srgbClr val="A3E635"/>
+                </a:solidFill>
+              </a:defRPr>
+            </a:pPr>
+            <a:r>
+              <a:t>• Feed Editorial Curado: </a:t>
             </a:r>
           </a:p>
           <a:p>
@@ -3601,20 +4062,19 @@
               </a:defRPr>
             </a:pPr>
             <a:r>
-              <a:t>  +5 nfs por ler artigos, +10 nfs por compartilhar no WhatsApp, +50 nfs em compras.</a:t>
-            </a:r>
-            <a:br/>
-          </a:p>
-          <a:p>
-            <a:pPr>
-              <a:defRPr sz="1200" b="1">
-                <a:solidFill>
-                  <a:srgbClr val="84CC16"/>
-                </a:solidFill>
-              </a:defRPr>
-            </a:pPr>
-            <a:r>
-              <a:t>• Valor Imediato no Dia 1: </a:t>
+              <a:t>  Conteúdo transacional que recompensa leitura e compartilhamento com pontos nfs.</a:t>
+            </a:r>
+          </a:p>
+          <a:p>
+            <a:pPr>
+              <a:defRPr sz="1300" b="1">
+                <a:solidFill>
+                  <a:srgbClr val="A3E635"/>
+                </a:solidFill>
+              </a:defRPr>
+            </a:pPr>
+            <a:r>
+              <a:t>• Netfits Shop Marketplace: </a:t>
             </a:r>
           </a:p>
           <a:p>
@@ -3626,20 +4086,19 @@
               </a:defRPr>
             </a:pPr>
             <a:r>
-              <a:t>  Sem cadastro complexo ou dependência de wearables para gerar os primeiros benefícios.</a:t>
-            </a:r>
-            <a:br/>
-          </a:p>
-          <a:p>
-            <a:pPr>
-              <a:defRPr sz="1200" b="1">
-                <a:solidFill>
-                  <a:srgbClr val="84CC16"/>
-                </a:solidFill>
-              </a:defRPr>
-            </a:pPr>
-            <a:r>
-              <a:t>• Healthspan, Não Culto à Performance: </a:t>
+              <a:t>  Compra com cashback em pontos e Take Rate padrão de 8,0%.</a:t>
+            </a:r>
+          </a:p>
+          <a:p>
+            <a:pPr>
+              <a:defRPr sz="1300" b="1">
+                <a:solidFill>
+                  <a:srgbClr val="A3E635"/>
+                </a:solidFill>
+              </a:defRPr>
+            </a:pPr>
+            <a:r>
+              <a:t>• As 3 Camadas do Manifesto: </a:t>
             </a:r>
           </a:p>
           <a:p>
@@ -3651,20 +4110,19 @@
               </a:defRPr>
             </a:pPr>
             <a:r>
-              <a:t>  Consistência e vitalidade sem culto à comparação corporal ou promessas clínicas.</a:t>
-            </a:r>
-            <a:br/>
-          </a:p>
-          <a:p>
-            <a:pPr>
-              <a:defRPr sz="1200" b="1">
-                <a:solidFill>
-                  <a:srgbClr val="84CC16"/>
-                </a:solidFill>
-              </a:defRPr>
-            </a:pPr>
-            <a:r>
-              <a:t>• Algoritmo FEFO Protegido: </a:t>
+              <a:t>  1. Benefícios &amp; Commerce ➔ 2. Hábitos &amp; Wearables (Garmin/Strava) ➔ 3. Longevidade Consciente.</a:t>
+            </a:r>
+          </a:p>
+          <a:p>
+            <a:pPr>
+              <a:defRPr sz="1300" b="1">
+                <a:solidFill>
+                  <a:srgbClr val="A3E635"/>
+                </a:solidFill>
+              </a:defRPr>
+            </a:pPr>
+            <a:r>
+              <a:t>• MTP (Massive Transformative Purpose): </a:t>
             </a:r>
           </a:p>
           <a:p>
@@ -3676,9 +4134,8 @@
               </a:defRPr>
             </a:pPr>
             <a:r>
-              <a:t>  Consumo prioritário dos pontos mais próximos de expirar.</a:t>
-            </a:r>
-            <a:br/>
+              <a:t>  Recompensar quem se movimenta.</a:t>
+            </a:r>
           </a:p>
         </p:txBody>
       </p:sp>
@@ -3720,7 +4177,7 @@
     <p:bg>
       <p:bgPr>
         <a:solidFill>
-          <a:srgbClr val="0F0F14"/>
+          <a:srgbClr val="09090B"/>
         </a:solidFill>
         <a:effectLst/>
       </p:bgPr>
@@ -3757,13 +4214,12 @@
             <a:pPr>
               <a:defRPr sz="1000" b="1">
                 <a:solidFill>
-                  <a:srgbClr val="84CC16"/>
-                </a:solidFill>
-                <a:latin typeface="Calibri"/>
-              </a:defRPr>
-            </a:pPr>
-            <a:r>
-              <a:t>NETFITS TECNOLOGIA S.A.</a:t>
+                  <a:srgbClr val="A3E635"/>
+                </a:solidFill>
+              </a:defRPr>
+            </a:pPr>
+            <a:r>
+              <a:t>NETFITS FIDELIDADE LTDA.</a:t>
             </a:r>
           </a:p>
           <a:p>
@@ -3772,11 +4228,10 @@
                 <a:solidFill>
                   <a:srgbClr val="FFFFFF"/>
                 </a:solidFill>
-                <a:latin typeface="Calibri"/>
-              </a:defRPr>
-            </a:pPr>
-            <a:r>
-              <a:t>🤝 Canais B2B2C &amp; Categoria Única de Associados Netfits (10,0%)</a:t>
+              </a:defRPr>
+            </a:pPr>
+            <a:r>
+              <a:t>🛒 Netfits Shop Marketplace: Ofertas Curadas &amp; Cashback em Pontos</a:t>
             </a:r>
           </a:p>
         </p:txBody>
@@ -3789,8 +4244,8 @@
         </p:nvSpPr>
         <p:spPr>
           <a:xfrm>
-            <a:off x="731520" y="1463040"/>
-            <a:ext cx="10698480" cy="4572000"/>
+            <a:off x="731520" y="1371600"/>
+            <a:ext cx="5669280" cy="4846320"/>
           </a:xfrm>
           <a:prstGeom prst="rect">
             <a:avLst/>
@@ -3805,81 +4260,126 @@
           <a:p/>
           <a:p>
             <a:pPr>
-              <a:defRPr sz="1400" b="1">
-                <a:solidFill>
-                  <a:srgbClr val="84CC16"/>
-                </a:solidFill>
-              </a:defRPr>
-            </a:pPr>
-            <a:r>
-              <a:t>• Categoria Única de Associados Netfits: </a:t>
-            </a:r>
-          </a:p>
-          <a:p>
-            <a:pPr>
-              <a:defRPr sz="1200">
+              <a:defRPr sz="1300" b="1">
+                <a:solidFill>
+                  <a:srgbClr val="A3E635"/>
+                </a:solidFill>
+              </a:defRPr>
+            </a:pPr>
+            <a:r>
+              <a:t>• Take Rate Padrão de 8,0%: </a:t>
+            </a:r>
+          </a:p>
+          <a:p>
+            <a:pPr>
+              <a:defRPr sz="1100">
                 <a:solidFill>
                   <a:srgbClr val="FFFFFF"/>
                 </a:solidFill>
               </a:defRPr>
             </a:pPr>
             <a:r>
-              <a:t>  Comissão padrão de 10,0% repassada diretamente sobre as receitas geradas pela rede.</a:t>
-            </a:r>
-            <a:br/>
-          </a:p>
-          <a:p>
-            <a:pPr>
-              <a:defRPr sz="1400" b="1">
-                <a:solidFill>
-                  <a:srgbClr val="84CC16"/>
-                </a:solidFill>
-              </a:defRPr>
-            </a:pPr>
-            <a:r>
-              <a:t>• Escala por Influência &amp; Atendimento: </a:t>
-            </a:r>
-          </a:p>
-          <a:p>
-            <a:pPr>
-              <a:defRPr sz="1200">
+              <a:t>  Remuneração direta sobre o GMV de produtos esportivos, suplementos, acessórios e provas.</a:t>
+            </a:r>
+          </a:p>
+          <a:p>
+            <a:pPr>
+              <a:defRPr sz="1300" b="1">
+                <a:solidFill>
+                  <a:srgbClr val="A3E635"/>
+                </a:solidFill>
+              </a:defRPr>
+            </a:pPr>
+            <a:r>
+              <a:t>• Checkout Unificado &amp; Parceiros: </a:t>
+            </a:r>
+          </a:p>
+          <a:p>
+            <a:pPr>
+              <a:defRPr sz="1100">
                 <a:solidFill>
                   <a:srgbClr val="FFFFFF"/>
                 </a:solidFill>
               </a:defRPr>
             </a:pPr>
             <a:r>
-              <a:t>  Studios, assessorias de corrida, médicos esportivos e criadores de conteúdo ativados.</a:t>
-            </a:r>
-            <a:br/>
-          </a:p>
-          <a:p>
-            <a:pPr>
-              <a:defRPr sz="1400" b="1">
-                <a:solidFill>
-                  <a:srgbClr val="84CC16"/>
-                </a:solidFill>
-              </a:defRPr>
-            </a:pPr>
-            <a:r>
-              <a:t>• MGM (Member Get Member): </a:t>
-            </a:r>
-          </a:p>
-          <a:p>
-            <a:pPr>
-              <a:defRPr sz="1200">
+              <a:t>  Operado em parceria com grandes marcas e e-commerces esportivos com postback automatizado.</a:t>
+            </a:r>
+          </a:p>
+          <a:p>
+            <a:pPr>
+              <a:defRPr sz="1300" b="1">
+                <a:solidFill>
+                  <a:srgbClr val="A3E635"/>
+                </a:solidFill>
+              </a:defRPr>
+            </a:pPr>
+            <a:r>
+              <a:t>• Bônus de 1ª Compra: </a:t>
+            </a:r>
+          </a:p>
+          <a:p>
+            <a:pPr>
+              <a:defRPr sz="1100">
                 <a:solidFill>
                   <a:srgbClr val="FFFFFF"/>
                 </a:solidFill>
               </a:defRPr>
             </a:pPr>
             <a:r>
-              <a:t>  Remuneração direta por novas assinaturas do Netfits Club e vendas no Marketplace.</a:t>
-            </a:r>
-            <a:br/>
-          </a:p>
-        </p:txBody>
-      </p:sp>
+              <a:t>  Concessão de 150 nfs para incentivar a primeira conversão no Shop.</a:t>
+            </a:r>
+          </a:p>
+          <a:p>
+            <a:pPr>
+              <a:defRPr sz="1300" b="1">
+                <a:solidFill>
+                  <a:srgbClr val="A3E635"/>
+                </a:solidFill>
+              </a:defRPr>
+            </a:pPr>
+            <a:r>
+              <a:t>• Monetização sem Estoque: </a:t>
+            </a:r>
+          </a:p>
+          <a:p>
+            <a:pPr>
+              <a:defRPr sz="1100">
+                <a:solidFill>
+                  <a:srgbClr val="FFFFFF"/>
+                </a:solidFill>
+              </a:defRPr>
+            </a:pPr>
+            <a:r>
+              <a:t>  Zero risco de estoque ou logística própria no modelo de marketplace afiliado/credenciado.</a:t>
+            </a:r>
+          </a:p>
+        </p:txBody>
+      </p:sp>
+      <p:pic>
+        <p:nvPicPr>
+          <p:cNvPr id="4" name="Picture 3" descr="real_netfits_feed.png"/>
+          <p:cNvPicPr>
+            <a:picLocks noChangeAspect="1"/>
+          </p:cNvPicPr>
+          <p:nvPr/>
+        </p:nvPicPr>
+        <p:blipFill>
+          <a:blip r:embed="rId2"/>
+          <a:stretch>
+            <a:fillRect/>
+          </a:stretch>
+        </p:blipFill>
+        <p:spPr>
+          <a:xfrm>
+            <a:off x="6583680" y="1371600"/>
+            <a:ext cx="4846320" cy="3407569"/>
+          </a:xfrm>
+          <a:prstGeom prst="rect">
+            <a:avLst/>
+          </a:prstGeom>
+        </p:spPr>
+      </p:pic>
     </p:spTree>
   </p:cSld>
   <p:clrMapOvr>
@@ -3894,7 +4394,7 @@
     <p:bg>
       <p:bgPr>
         <a:solidFill>
-          <a:srgbClr val="0F0F14"/>
+          <a:srgbClr val="09090B"/>
         </a:solidFill>
         <a:effectLst/>
       </p:bgPr>
@@ -3931,13 +4431,12 @@
             <a:pPr>
               <a:defRPr sz="1000" b="1">
                 <a:solidFill>
-                  <a:srgbClr val="84CC16"/>
-                </a:solidFill>
-                <a:latin typeface="Calibri"/>
-              </a:defRPr>
-            </a:pPr>
-            <a:r>
-              <a:t>NETFITS TECNOLOGIA S.A.</a:t>
+                  <a:srgbClr val="A3E635"/>
+                </a:solidFill>
+              </a:defRPr>
+            </a:pPr>
+            <a:r>
+              <a:t>NETFITS FIDELIDADE LTDA.</a:t>
             </a:r>
           </a:p>
           <a:p>
@@ -3946,11 +4445,10 @@
                 <a:solidFill>
                   <a:srgbClr val="FFFFFF"/>
                 </a:solidFill>
-                <a:latin typeface="Calibri"/>
-              </a:defRPr>
-            </a:pPr>
-            <a:r>
-              <a:t>🛍️ Netfits Shop — Captura Real do Marketplace do App</a:t>
+              </a:defRPr>
+            </a:pPr>
+            <a:r>
+              <a:t>💳 Carteira nfs: Algoritmo FEFO &amp; Engenharia Atuarial de Pontos</a:t>
             </a:r>
           </a:p>
         </p:txBody>
@@ -3963,8 +4461,8 @@
         </p:nvSpPr>
         <p:spPr>
           <a:xfrm>
-            <a:off x="731520" y="1463040"/>
-            <a:ext cx="5486400" cy="4572000"/>
+            <a:off x="731520" y="1371600"/>
+            <a:ext cx="5669280" cy="4846320"/>
           </a:xfrm>
           <a:prstGeom prst="rect">
             <a:avLst/>
@@ -3979,14 +4477,14 @@
           <a:p/>
           <a:p>
             <a:pPr>
-              <a:defRPr sz="1200" b="1">
-                <a:solidFill>
-                  <a:srgbClr val="84CC16"/>
-                </a:solidFill>
-              </a:defRPr>
-            </a:pPr>
-            <a:r>
-              <a:t>• 8,0% Take-Rate Padrão no GMV: </a:t>
+              <a:defRPr sz="1300" b="1">
+                <a:solidFill>
+                  <a:srgbClr val="A3E635"/>
+                </a:solidFill>
+              </a:defRPr>
+            </a:pPr>
+            <a:r>
+              <a:t>• Algoritmo FEFO (First-Expiring, First-Out): </a:t>
             </a:r>
           </a:p>
           <a:p>
@@ -3998,20 +4496,19 @@
               </a:defRPr>
             </a:pPr>
             <a:r>
-              <a:t>  Comissão padrão sobre o GMV dos sellers credenciados.</a:t>
-            </a:r>
-            <a:br/>
-          </a:p>
-          <a:p>
-            <a:pPr>
-              <a:defRPr sz="1200" b="1">
-                <a:solidFill>
-                  <a:srgbClr val="84CC16"/>
-                </a:solidFill>
-              </a:defRPr>
-            </a:pPr>
-            <a:r>
-              <a:t>• Cashback Transparente em nfs: </a:t>
+              <a:t>  Resgate prioritário automático do ponto mais próximo de vencer, protegendo o usuário.</a:t>
+            </a:r>
+          </a:p>
+          <a:p>
+            <a:pPr>
+              <a:defRPr sz="1300" b="1">
+                <a:solidFill>
+                  <a:srgbClr val="A3E635"/>
+                </a:solidFill>
+              </a:defRPr>
+            </a:pPr>
+            <a:r>
+              <a:t>• Sustentabilidade Atuarial: </a:t>
             </a:r>
           </a:p>
           <a:p>
@@ -4023,20 +4520,19 @@
               </a:defRPr>
             </a:pPr>
             <a:r>
-              <a:t>  Selo visual '+50 nfs cashback' em produtos esportivos.</a:t>
-            </a:r>
-            <a:br/>
-          </a:p>
-          <a:p>
-            <a:pPr>
-              <a:defRPr sz="1200" b="1">
-                <a:solidFill>
-                  <a:srgbClr val="84CC16"/>
-                </a:solidFill>
-              </a:defRPr>
-            </a:pPr>
-            <a:r>
-              <a:t>• Categorias Curadas: </a:t>
+              <a:t>  Regra de Ouro: 'Pontos sem funding viram passivo; pontos com funding viram motor de crescimento'.</a:t>
+            </a:r>
+          </a:p>
+          <a:p>
+            <a:pPr>
+              <a:defRPr sz="1300" b="1">
+                <a:solidFill>
+                  <a:srgbClr val="A3E635"/>
+                </a:solidFill>
+              </a:defRPr>
+            </a:pPr>
+            <a:r>
+              <a:t>• CPP Acúmulo &amp; Resgate: </a:t>
             </a:r>
           </a:p>
           <a:p>
@@ -4048,20 +4544,19 @@
               </a:defRPr>
             </a:pPr>
             <a:r>
-              <a:t>  Tênis, wearables, suplementos, inscrições em corridas e recovery.</a:t>
-            </a:r>
-            <a:br/>
-          </a:p>
-          <a:p>
-            <a:pPr>
-              <a:defRPr sz="1200" b="1">
-                <a:solidFill>
-                  <a:srgbClr val="84CC16"/>
-                </a:solidFill>
-              </a:defRPr>
-            </a:pPr>
-            <a:r>
-              <a:t>• Conversão Sem Atrito: </a:t>
+              <a:t>  CPP Acúmulo R$ 0,02 | CPP Resgate R$ 0,01 | Passivo Retido R$ 0,01.</a:t>
+            </a:r>
+          </a:p>
+          <a:p>
+            <a:pPr>
+              <a:defRPr sz="1300" b="1">
+                <a:solidFill>
+                  <a:srgbClr val="A3E635"/>
+                </a:solidFill>
+              </a:defRPr>
+            </a:pPr>
+            <a:r>
+              <a:t>• Reserva do Passivo Retido: </a:t>
             </a:r>
           </a:p>
           <a:p>
@@ -4073,9 +4568,8 @@
               </a:defRPr>
             </a:pPr>
             <a:r>
-              <a:t>  Integração direta entre feed editorial e o e-commerce.</a:t>
-            </a:r>
-            <a:br/>
+              <a:t>  Retenção de R$ 88.842,00 em caixa garantindo 100% de solidez para resgates.</a:t>
+            </a:r>
           </a:p>
         </p:txBody>
       </p:sp>
@@ -4117,7 +4611,7 @@
     <p:bg>
       <p:bgPr>
         <a:solidFill>
-          <a:srgbClr val="0F0F14"/>
+          <a:srgbClr val="09090B"/>
         </a:solidFill>
         <a:effectLst/>
       </p:bgPr>
@@ -4154,13 +4648,12 @@
             <a:pPr>
               <a:defRPr sz="1000" b="1">
                 <a:solidFill>
-                  <a:srgbClr val="84CC16"/>
-                </a:solidFill>
-                <a:latin typeface="Calibri"/>
-              </a:defRPr>
-            </a:pPr>
-            <a:r>
-              <a:t>NETFITS TECNOLOGIA S.A.</a:t>
+                  <a:srgbClr val="A3E635"/>
+                </a:solidFill>
+              </a:defRPr>
+            </a:pPr>
+            <a:r>
+              <a:t>NETFITS FIDELIDADE LTDA.</a:t>
             </a:r>
           </a:p>
           <a:p>
@@ -4169,11 +4662,10 @@
                 <a:solidFill>
                   <a:srgbClr val="FFFFFF"/>
                 </a:solidFill>
-                <a:latin typeface="Calibri"/>
-              </a:defRPr>
-            </a:pPr>
-            <a:r>
-              <a:t>🪙 Carteira nfs &amp; FEFO — Captura Real da Wallet do App</a:t>
+              </a:defRPr>
+            </a:pPr>
+            <a:r>
+              <a:t>📈 DRE Proforma: Fase 1 Launch vs Fase 2 Com Clube (R$ 19,90/mês)</a:t>
             </a:r>
           </a:p>
         </p:txBody>
@@ -4186,8 +4678,8 @@
         </p:nvSpPr>
         <p:spPr>
           <a:xfrm>
-            <a:off x="731520" y="1463040"/>
-            <a:ext cx="5486400" cy="4572000"/>
+            <a:off x="731520" y="1371600"/>
+            <a:ext cx="4754880" cy="4846320"/>
           </a:xfrm>
           <a:prstGeom prst="rect">
             <a:avLst/>
@@ -4204,107 +4696,103 @@
             <a:pPr>
               <a:defRPr sz="1200" b="1">
                 <a:solidFill>
-                  <a:srgbClr val="84CC16"/>
-                </a:solidFill>
-              </a:defRPr>
-            </a:pPr>
-            <a:r>
-              <a:t>• CPP de Acúmulo vs Resgate: </a:t>
-            </a:r>
-          </a:p>
-          <a:p>
-            <a:pPr>
-              <a:defRPr sz="1100">
+                  <a:srgbClr val="A3E635"/>
+                </a:solidFill>
+              </a:defRPr>
+            </a:pPr>
+            <a:r>
+              <a:t>• Fase 1 (Launch Inicial): </a:t>
+            </a:r>
+          </a:p>
+          <a:p>
+            <a:pPr>
+              <a:defRPr sz="1000">
                 <a:solidFill>
                   <a:srgbClr val="FFFFFF"/>
                 </a:solidFill>
               </a:defRPr>
             </a:pPr>
             <a:r>
-              <a:t>  CPP Acúmulo: R$ 0,02/nfs | CPP Resgate: R$ 0,01/nfs | Custo Provisão: R$ 0,01/nfs.</a:t>
-            </a:r>
-            <a:br/>
+              <a:t>  Receita Bruta R$ 893.850,00 | EBITDA R$ 157.625,40 (17,6%) | Lucro Líquido R$ 129.895,34 (14,5%).</a:t>
+            </a:r>
           </a:p>
           <a:p>
             <a:pPr>
               <a:defRPr sz="1200" b="1">
                 <a:solidFill>
-                  <a:srgbClr val="84CC16"/>
-                </a:solidFill>
-              </a:defRPr>
-            </a:pPr>
-            <a:r>
-              <a:t>• Fila de Validade FEFO: </a:t>
-            </a:r>
-          </a:p>
-          <a:p>
-            <a:pPr>
-              <a:defRPr sz="1100">
+                  <a:srgbClr val="A3E635"/>
+                </a:solidFill>
+              </a:defRPr>
+            </a:pPr>
+            <a:r>
+              <a:t>• Fase 2 (Com Netfits Club): </a:t>
+            </a:r>
+          </a:p>
+          <a:p>
+            <a:pPr>
+              <a:defRPr sz="1000">
                 <a:solidFill>
                   <a:srgbClr val="FFFFFF"/>
                 </a:solidFill>
               </a:defRPr>
             </a:pPr>
             <a:r>
-              <a:t>  Lotes organizados com tag visual '1º A ser consumido'.</a:t>
-            </a:r>
-            <a:br/>
+              <a:t>  Receita Bruta R$ 1.789.350,00 | EBITDA R$ 963.080,40 (53,8%) | Lucro Líquido R$ 815.958,34 (45,6%).</a:t>
+            </a:r>
           </a:p>
           <a:p>
             <a:pPr>
               <a:defRPr sz="1200" b="1">
                 <a:solidFill>
-                  <a:srgbClr val="84CC16"/>
-                </a:solidFill>
-              </a:defRPr>
-            </a:pPr>
-            <a:r>
-              <a:t>• Declaração de Pontos de Bancos: </a:t>
-            </a:r>
-          </a:p>
-          <a:p>
-            <a:pPr>
-              <a:defRPr sz="1100">
+                  <a:srgbClr val="A3E635"/>
+                </a:solidFill>
+              </a:defRPr>
+            </a:pPr>
+            <a:r>
+              <a:t>• Margem Bruta Ajustada: </a:t>
+            </a:r>
+          </a:p>
+          <a:p>
+            <a:pPr>
+              <a:defRPr sz="1000">
                 <a:solidFill>
                   <a:srgbClr val="FFFFFF"/>
                 </a:solidFill>
               </a:defRPr>
             </a:pPr>
             <a:r>
-              <a:t>  Conector para Livelo, Esfera, Átomos, Smiles e LATAM Pass.</a:t>
-            </a:r>
-            <a:br/>
+              <a:t>  Evolução de 62,6% na Fase 1 para 79,3% na Fase 2 com diluição de custos fixos.</a:t>
+            </a:r>
           </a:p>
           <a:p>
             <a:pPr>
               <a:defRPr sz="1200" b="1">
                 <a:solidFill>
-                  <a:srgbClr val="84CC16"/>
-                </a:solidFill>
-              </a:defRPr>
-            </a:pPr>
-            <a:r>
-              <a:t>• Passivo Retido em Caixa: </a:t>
-            </a:r>
-          </a:p>
-          <a:p>
-            <a:pPr>
-              <a:defRPr sz="1100">
+                  <a:srgbClr val="A3E635"/>
+                </a:solidFill>
+              </a:defRPr>
+            </a:pPr>
+            <a:r>
+              <a:t>• Reversão de Provisão DRE: </a:t>
+            </a:r>
+          </a:p>
+          <a:p>
+            <a:pPr>
+              <a:defRPr sz="1000">
                 <a:solidFill>
                   <a:srgbClr val="FFFFFF"/>
                 </a:solidFill>
               </a:defRPr>
             </a:pPr>
             <a:r>
-              <a:t>  Reserva atuarial de R$ 88.842,00 (100% Solvente).</a:t>
-            </a:r>
-            <a:br/>
+              <a:t>  Reversão contabilizada de pontos expirados (Breakage 12,0%) diretamente no resultado.</a:t>
+            </a:r>
           </a:p>
         </p:txBody>
       </p:sp>
       <p:pic>
         <p:nvPicPr>
-          <p:cNvPr id="4" name="Picture 3" descr="real_netfits_feed.png"/>
+          <p:cNvPr id="4" name="Picture 3" descr="real_netfits_admin_dre.png"/>
           <p:cNvPicPr>
             <a:picLocks noChangeAspect="1"/>
           </p:cNvPicPr>
@@ -4318,8 +4806,8 @@
         </p:blipFill>
         <p:spPr>
           <a:xfrm>
-            <a:off x="6583680" y="1371600"/>
-            <a:ext cx="4846320" cy="3407569"/>
+            <a:off x="5669280" y="1371600"/>
+            <a:ext cx="5760720" cy="3600450"/>
           </a:xfrm>
           <a:prstGeom prst="rect">
             <a:avLst/>
@@ -4340,7 +4828,7 @@
     <p:bg>
       <p:bgPr>
         <a:solidFill>
-          <a:srgbClr val="0F0F14"/>
+          <a:srgbClr val="09090B"/>
         </a:solidFill>
         <a:effectLst/>
       </p:bgPr>
@@ -4377,13 +4865,12 @@
             <a:pPr>
               <a:defRPr sz="1000" b="1">
                 <a:solidFill>
-                  <a:srgbClr val="84CC16"/>
-                </a:solidFill>
-                <a:latin typeface="Calibri"/>
-              </a:defRPr>
-            </a:pPr>
-            <a:r>
-              <a:t>NETFITS TECNOLOGIA S.A.</a:t>
+                  <a:srgbClr val="A3E635"/>
+                </a:solidFill>
+              </a:defRPr>
+            </a:pPr>
+            <a:r>
+              <a:t>NETFITS FIDELIDADE LTDA.</a:t>
             </a:r>
           </a:p>
           <a:p>
@@ -4392,11 +4879,10 @@
                 <a:solidFill>
                   <a:srgbClr val="FFFFFF"/>
                 </a:solidFill>
-                <a:latin typeface="Calibri"/>
-              </a:defRPr>
-            </a:pPr>
-            <a:r>
-              <a:t>📈 DRE Financeiro Executivo — Captura Real do Painel Admin</a:t>
+              </a:defRPr>
+            </a:pPr>
+            <a:r>
+              <a:t>📊 Tamanho de Mercado &amp; Oportunidade na América Latina</a:t>
             </a:r>
           </a:p>
         </p:txBody>
@@ -4410,7 +4896,7 @@
         <p:spPr>
           <a:xfrm>
             <a:off x="731520" y="1463040"/>
-            <a:ext cx="5486400" cy="4572000"/>
+            <a:ext cx="10698480" cy="4572000"/>
           </a:xfrm>
           <a:prstGeom prst="rect">
             <a:avLst/>
@@ -4425,130 +4911,450 @@
           <a:p/>
           <a:p>
             <a:pPr>
-              <a:defRPr sz="1200" b="1">
-                <a:solidFill>
-                  <a:srgbClr val="84CC16"/>
-                </a:solidFill>
-              </a:defRPr>
-            </a:pPr>
-            <a:r>
-              <a:t>• Fase 1 (Launch Inicial Sem Clube): </a:t>
-            </a:r>
-          </a:p>
-          <a:p>
-            <a:pPr>
-              <a:defRPr sz="1100">
+              <a:defRPr sz="1400" b="1">
+                <a:solidFill>
+                  <a:srgbClr val="C084FC"/>
+                </a:solidFill>
+              </a:defRPr>
+            </a:pPr>
+            <a:r>
+              <a:t>• TAM (Total Addressable Market): </a:t>
+            </a:r>
+          </a:p>
+          <a:p>
+            <a:pPr>
+              <a:defRPr sz="1200">
                 <a:solidFill>
                   <a:srgbClr val="FFFFFF"/>
                 </a:solidFill>
               </a:defRPr>
             </a:pPr>
             <a:r>
-              <a:t>  Receita Bruta R$ 893.850,00 | EBITDA R$ 157.625,40 (17,6% Margem).</a:t>
+              <a:t>  25 a 35 Milhões de esportistas amadores no Brasil que buscam saúde, esporte e longevidade.</a:t>
             </a:r>
             <a:br/>
           </a:p>
           <a:p>
             <a:pPr>
-              <a:defRPr sz="1200" b="1">
-                <a:solidFill>
-                  <a:srgbClr val="84CC16"/>
-                </a:solidFill>
-              </a:defRPr>
-            </a:pPr>
-            <a:r>
-              <a:t>• Fase 2 (Expansão Com Clube R$ 19,90/m): </a:t>
-            </a:r>
-          </a:p>
-          <a:p>
-            <a:pPr>
-              <a:defRPr sz="1100">
+              <a:defRPr sz="1400" b="1">
+                <a:solidFill>
+                  <a:srgbClr val="C084FC"/>
+                </a:solidFill>
+              </a:defRPr>
+            </a:pPr>
+            <a:r>
+              <a:t>• SAM (Serviceable Addressable Market): </a:t>
+            </a:r>
+          </a:p>
+          <a:p>
+            <a:pPr>
+              <a:defRPr sz="1200">
                 <a:solidFill>
                   <a:srgbClr val="FFFFFF"/>
                 </a:solidFill>
               </a:defRPr>
             </a:pPr>
             <a:r>
-              <a:t>  Receita Bruta R$ 1.789.350,00 | EBITDA R$ 963.080,40 (53,8% Margem).</a:t>
+              <a:t>  R$ 4,0 Bilhões transacionados anualmente em e-commerce esportivo, suplementos e provas.</a:t>
             </a:r>
             <a:br/>
           </a:p>
           <a:p>
             <a:pPr>
-              <a:defRPr sz="1200" b="1">
-                <a:solidFill>
-                  <a:srgbClr val="84CC16"/>
-                </a:solidFill>
-              </a:defRPr>
-            </a:pPr>
-            <a:r>
-              <a:t>• Lucro Líquido do Exercício: </a:t>
-            </a:r>
-          </a:p>
-          <a:p>
-            <a:pPr>
-              <a:defRPr sz="1100">
+              <a:defRPr sz="1400" b="1">
+                <a:solidFill>
+                  <a:srgbClr val="C084FC"/>
+                </a:solidFill>
+              </a:defRPr>
+            </a:pPr>
+            <a:r>
+              <a:t>• SOM (Serviceable Obtainable Market): </a:t>
+            </a:r>
+          </a:p>
+          <a:p>
+            <a:pPr>
+              <a:defRPr sz="1200">
                 <a:solidFill>
                   <a:srgbClr val="FFFFFF"/>
                 </a:solidFill>
               </a:defRPr>
             </a:pPr>
             <a:r>
-              <a:t>  Fase 1: R$ 129.895,34 (14,5%) -&gt; Fase 2: R$ 815.958,34 (45,6%).</a:t>
+              <a:t>  R$ 100M a R$ 150M de GMV no Ano 2 ➔ R$ 400M a R$ 700M de GMV no Ano 3.</a:t>
             </a:r>
             <a:br/>
           </a:p>
-          <a:p>
-            <a:pPr>
-              <a:defRPr sz="1200" b="1">
-                <a:solidFill>
-                  <a:srgbClr val="84CC16"/>
-                </a:solidFill>
-              </a:defRPr>
-            </a:pPr>
-            <a:r>
-              <a:t>• Uso dos Recursos (Rodada Seed R$ 4M-8M): </a:t>
-            </a:r>
-          </a:p>
-          <a:p>
-            <a:pPr>
-              <a:defRPr sz="1100">
-                <a:solidFill>
-                  <a:srgbClr val="FFFFFF"/>
-                </a:solidFill>
-              </a:defRPr>
-            </a:pPr>
-            <a:r>
-              <a:t>  40% Tecnologia, 25% Growth, 15% Comercial, 10% BI/Antifraude, 10% G&amp;A.</a:t>
-            </a:r>
-            <a:br/>
-          </a:p>
-        </p:txBody>
-      </p:sp>
-      <p:pic>
-        <p:nvPicPr>
-          <p:cNvPr id="4" name="Picture 3" descr="real_netfits_admin_dre.png"/>
-          <p:cNvPicPr>
-            <a:picLocks noChangeAspect="1"/>
-          </p:cNvPicPr>
+        </p:txBody>
+      </p:sp>
+    </p:spTree>
+  </p:cSld>
+  <p:clrMapOvr>
+    <a:masterClrMapping/>
+  </p:clrMapOvr>
+</p:sld>
+</file>
+
+<file path=ppt/slides/slide8.xml><?xml version="1.0" encoding="utf-8"?>
+<p:sld xmlns:a="http://schemas.openxmlformats.org/drawingml/2006/main" xmlns:p="http://schemas.openxmlformats.org/presentationml/2006/main" xmlns:r="http://schemas.openxmlformats.org/officeDocument/2006/relationships">
+  <p:cSld>
+    <p:bg>
+      <p:bgPr>
+        <a:solidFill>
+          <a:srgbClr val="09090B"/>
+        </a:solidFill>
+        <a:effectLst/>
+      </p:bgPr>
+    </p:bg>
+    <p:spTree>
+      <p:nvGrpSpPr>
+        <p:cNvPr id="1" name=""/>
+        <p:cNvGrpSpPr/>
+        <p:nvPr/>
+      </p:nvGrpSpPr>
+      <p:grpSpPr/>
+      <p:sp>
+        <p:nvSpPr>
+          <p:cNvPr id="2" name="TextBox 1"/>
+          <p:cNvSpPr txBox="1"/>
           <p:nvPr/>
-        </p:nvPicPr>
-        <p:blipFill>
-          <a:blip r:embed="rId2"/>
-          <a:stretch>
-            <a:fillRect/>
-          </a:stretch>
-        </p:blipFill>
+        </p:nvSpPr>
         <p:spPr>
           <a:xfrm>
-            <a:off x="6583680" y="1371600"/>
-            <a:ext cx="4846320" cy="3028950"/>
+            <a:off x="731520" y="365760"/>
+            <a:ext cx="10698480" cy="822960"/>
           </a:xfrm>
           <a:prstGeom prst="rect">
             <a:avLst/>
           </a:prstGeom>
+          <a:noFill/>
         </p:spPr>
-      </p:pic>
+        <p:txBody>
+          <a:bodyPr wrap="square">
+            <a:spAutoFit/>
+          </a:bodyPr>
+          <a:lstStyle/>
+          <a:p>
+            <a:pPr>
+              <a:defRPr sz="1000" b="1">
+                <a:solidFill>
+                  <a:srgbClr val="A3E635"/>
+                </a:solidFill>
+              </a:defRPr>
+            </a:pPr>
+            <a:r>
+              <a:t>NETFITS FIDELIDADE LTDA.</a:t>
+            </a:r>
+          </a:p>
+          <a:p>
+            <a:pPr>
+              <a:defRPr sz="2200" b="1">
+                <a:solidFill>
+                  <a:srgbClr val="FFFFFF"/>
+                </a:solidFill>
+              </a:defRPr>
+            </a:pPr>
+            <a:r>
+              <a:t>🎯 Unit Economics &amp; Eficiência de Capital</a:t>
+            </a:r>
+          </a:p>
+        </p:txBody>
+      </p:sp>
+      <p:sp>
+        <p:nvSpPr>
+          <p:cNvPr id="3" name="TextBox 2"/>
+          <p:cNvSpPr txBox="1"/>
+          <p:nvPr/>
+        </p:nvSpPr>
+        <p:spPr>
+          <a:xfrm>
+            <a:off x="731520" y="1463040"/>
+            <a:ext cx="10698480" cy="4572000"/>
+          </a:xfrm>
+          <a:prstGeom prst="rect">
+            <a:avLst/>
+          </a:prstGeom>
+          <a:noFill/>
+        </p:spPr>
+        <p:txBody>
+          <a:bodyPr wrap="square">
+            <a:spAutoFit/>
+          </a:bodyPr>
+          <a:lstStyle/>
+          <a:p/>
+          <a:p>
+            <a:pPr>
+              <a:defRPr sz="1400" b="1">
+                <a:solidFill>
+                  <a:srgbClr val="A3E635"/>
+                </a:solidFill>
+              </a:defRPr>
+            </a:pPr>
+            <a:r>
+              <a:t>• CAC Orgânico / B2B2C: </a:t>
+            </a:r>
+          </a:p>
+          <a:p>
+            <a:pPr>
+              <a:defRPr sz="1200">
+                <a:solidFill>
+                  <a:srgbClr val="FFFFFF"/>
+                </a:solidFill>
+              </a:defRPr>
+            </a:pPr>
+            <a:r>
+              <a:t>  R$ 18,50 por usuário ativo (viabilizado por Associados e embaixadores de nicho).</a:t>
+            </a:r>
+            <a:br/>
+          </a:p>
+          <a:p>
+            <a:pPr>
+              <a:defRPr sz="1400" b="1">
+                <a:solidFill>
+                  <a:srgbClr val="A3E635"/>
+                </a:solidFill>
+              </a:defRPr>
+            </a:pPr>
+            <a:r>
+              <a:t>• LTV Estimado (Lifetime Value): </a:t>
+            </a:r>
+          </a:p>
+          <a:p>
+            <a:pPr>
+              <a:defRPr sz="1200">
+                <a:solidFill>
+                  <a:srgbClr val="FFFFFF"/>
+                </a:solidFill>
+              </a:defRPr>
+            </a:pPr>
+            <a:r>
+              <a:t>  R$ 380,00 por usuário (Netfits Club + compras no Shop + serviços de longevidade).</a:t>
+            </a:r>
+            <a:br/>
+          </a:p>
+          <a:p>
+            <a:pPr>
+              <a:defRPr sz="1400" b="1">
+                <a:solidFill>
+                  <a:srgbClr val="A3E635"/>
+                </a:solidFill>
+              </a:defRPr>
+            </a:pPr>
+            <a:r>
+              <a:t>• Relação LTV / CAC: </a:t>
+            </a:r>
+          </a:p>
+          <a:p>
+            <a:pPr>
+              <a:defRPr sz="1200">
+                <a:solidFill>
+                  <a:srgbClr val="FFFFFF"/>
+                </a:solidFill>
+              </a:defRPr>
+            </a:pPr>
+            <a:r>
+              <a:t>  LTV / CAC &gt; 20x garantindo alta eficiência de retorno do investimento.</a:t>
+            </a:r>
+            <a:br/>
+          </a:p>
+          <a:p>
+            <a:pPr>
+              <a:defRPr sz="1400" b="1">
+                <a:solidFill>
+                  <a:srgbClr val="A3E635"/>
+                </a:solidFill>
+              </a:defRPr>
+            </a:pPr>
+            <a:r>
+              <a:t>• Payback do CAC: </a:t>
+            </a:r>
+          </a:p>
+          <a:p>
+            <a:pPr>
+              <a:defRPr sz="1200">
+                <a:solidFill>
+                  <a:srgbClr val="FFFFFF"/>
+                </a:solidFill>
+              </a:defRPr>
+            </a:pPr>
+            <a:r>
+              <a:t>  Menos de 2,5 meses para recuperar o custo de aquisição do usuário.</a:t>
+            </a:r>
+            <a:br/>
+          </a:p>
+        </p:txBody>
+      </p:sp>
+    </p:spTree>
+  </p:cSld>
+  <p:clrMapOvr>
+    <a:masterClrMapping/>
+  </p:clrMapOvr>
+</p:sld>
+</file>
+
+<file path=ppt/slides/slide9.xml><?xml version="1.0" encoding="utf-8"?>
+<p:sld xmlns:a="http://schemas.openxmlformats.org/drawingml/2006/main" xmlns:p="http://schemas.openxmlformats.org/presentationml/2006/main" xmlns:r="http://schemas.openxmlformats.org/officeDocument/2006/relationships">
+  <p:cSld>
+    <p:bg>
+      <p:bgPr>
+        <a:solidFill>
+          <a:srgbClr val="09090B"/>
+        </a:solidFill>
+        <a:effectLst/>
+      </p:bgPr>
+    </p:bg>
+    <p:spTree>
+      <p:nvGrpSpPr>
+        <p:cNvPr id="1" name=""/>
+        <p:cNvGrpSpPr/>
+        <p:nvPr/>
+      </p:nvGrpSpPr>
+      <p:grpSpPr/>
+      <p:sp>
+        <p:nvSpPr>
+          <p:cNvPr id="2" name="TextBox 1"/>
+          <p:cNvSpPr txBox="1"/>
+          <p:nvPr/>
+        </p:nvSpPr>
+        <p:spPr>
+          <a:xfrm>
+            <a:off x="731520" y="365760"/>
+            <a:ext cx="10698480" cy="822960"/>
+          </a:xfrm>
+          <a:prstGeom prst="rect">
+            <a:avLst/>
+          </a:prstGeom>
+          <a:noFill/>
+        </p:spPr>
+        <p:txBody>
+          <a:bodyPr wrap="square">
+            <a:spAutoFit/>
+          </a:bodyPr>
+          <a:lstStyle/>
+          <a:p>
+            <a:pPr>
+              <a:defRPr sz="1000" b="1">
+                <a:solidFill>
+                  <a:srgbClr val="A3E635"/>
+                </a:solidFill>
+              </a:defRPr>
+            </a:pPr>
+            <a:r>
+              <a:t>NETFITS FIDELIDADE LTDA.</a:t>
+            </a:r>
+          </a:p>
+          <a:p>
+            <a:pPr>
+              <a:defRPr sz="2200" b="1">
+                <a:solidFill>
+                  <a:srgbClr val="FFFFFF"/>
+                </a:solidFill>
+              </a:defRPr>
+            </a:pPr>
+            <a:r>
+              <a:t>🤝 Canais B2B2C &amp; Categoria Única de Associados Netfits (10,0%)</a:t>
+            </a:r>
+          </a:p>
+        </p:txBody>
+      </p:sp>
+      <p:sp>
+        <p:nvSpPr>
+          <p:cNvPr id="3" name="TextBox 2"/>
+          <p:cNvSpPr txBox="1"/>
+          <p:nvPr/>
+        </p:nvSpPr>
+        <p:spPr>
+          <a:xfrm>
+            <a:off x="731520" y="1463040"/>
+            <a:ext cx="10698480" cy="4572000"/>
+          </a:xfrm>
+          <a:prstGeom prst="rect">
+            <a:avLst/>
+          </a:prstGeom>
+          <a:noFill/>
+        </p:spPr>
+        <p:txBody>
+          <a:bodyPr wrap="square">
+            <a:spAutoFit/>
+          </a:bodyPr>
+          <a:lstStyle/>
+          <a:p/>
+          <a:p>
+            <a:pPr>
+              <a:defRPr sz="1400" b="1">
+                <a:solidFill>
+                  <a:srgbClr val="A3E635"/>
+                </a:solidFill>
+              </a:defRPr>
+            </a:pPr>
+            <a:r>
+              <a:t>• Categoria Única de Associados Netfits: </a:t>
+            </a:r>
+          </a:p>
+          <a:p>
+            <a:pPr>
+              <a:defRPr sz="1200">
+                <a:solidFill>
+                  <a:srgbClr val="FFFFFF"/>
+                </a:solidFill>
+              </a:defRPr>
+            </a:pPr>
+            <a:r>
+              <a:t>  Comissão padrão de 10,0% repassada diretamente sobre as receitas geradas pela rede.</a:t>
+            </a:r>
+            <a:br/>
+          </a:p>
+          <a:p>
+            <a:pPr>
+              <a:defRPr sz="1400" b="1">
+                <a:solidFill>
+                  <a:srgbClr val="A3E635"/>
+                </a:solidFill>
+              </a:defRPr>
+            </a:pPr>
+            <a:r>
+              <a:t>• Atribuição Vitalícia de Carteira: </a:t>
+            </a:r>
+          </a:p>
+          <a:p>
+            <a:pPr>
+              <a:defRPr sz="1200">
+                <a:solidFill>
+                  <a:srgbClr val="FFFFFF"/>
+                </a:solidFill>
+              </a:defRPr>
+            </a:pPr>
+            <a:r>
+              <a:t>  Treinadores, assessorias, médicos e criadores recebem continuamente pelas vendas e assinaturas de seus indicados.</a:t>
+            </a:r>
+            <a:br/>
+          </a:p>
+          <a:p>
+            <a:pPr>
+              <a:defRPr sz="1400" b="1">
+                <a:solidFill>
+                  <a:srgbClr val="A3E635"/>
+                </a:solidFill>
+              </a:defRPr>
+            </a:pPr>
+            <a:r>
+              <a:t>• MGM (Member-Get-Member): </a:t>
+            </a:r>
+          </a:p>
+          <a:p>
+            <a:pPr>
+              <a:defRPr sz="1200">
+                <a:solidFill>
+                  <a:srgbClr val="FFFFFF"/>
+                </a:solidFill>
+              </a:defRPr>
+            </a:pPr>
+            <a:r>
+              <a:t>  Programa de indicação de amigos com bônus de 50 nfs no cadastro e 150 nfs na 1ª compra.</a:t>
+            </a:r>
+            <a:br/>
+          </a:p>
+        </p:txBody>
+      </p:sp>
     </p:spTree>
   </p:cSld>
   <p:clrMapOvr>

</xml_diff>

<commit_message>
feat: incorporar estimativas de custos da Cloud v2.4 no painel admin e materiais de investidores
</commit_message>
<xml_diff>
--- a/docs/Apresentacao_Investidores_Netfits_v1.pptx
+++ b/docs/Apresentacao_Investidores_Netfits_v1.pptx
@@ -5152,7 +5152,7 @@
               </a:defRPr>
             </a:pPr>
             <a:r>
-              <a:t>  LTV / CAC &gt; 20x garantindo alta eficiência de retorno do investimento.</a:t>
+              <a:t>  LTV / CAC &gt; 20x garantindo alta eficiência de retorno do investimento (Payback &lt; 2,5 meses).</a:t>
             </a:r>
             <a:br/>
           </a:p>
@@ -5165,7 +5165,7 @@
               </a:defRPr>
             </a:pPr>
             <a:r>
-              <a:t>• Payback do CAC: </a:t>
+              <a:t>• Infraestrutura Cloud Enterprise (v2.4): </a:t>
             </a:r>
           </a:p>
           <a:p>
@@ -5177,7 +5177,7 @@
               </a:defRPr>
             </a:pPr>
             <a:r>
-              <a:t>  Menos de 2,5 meses para recuperar o custo de aquisição do usuário.</a:t>
+              <a:t>  R$ 48.000/mês para 1M de usuários (600k MAU e 25k simultâneos no pico), representando apenas 1,65% da Receita Bruta e mantendo Margem EBITDA de 41,3%.</a:t>
             </a:r>
             <a:br/>
           </a:p>

</xml_diff>